<commit_message>
PW-CLI: created test files from testcase scenarios
</commit_message>
<xml_diff>
--- a/presentation/Playwright_CLI.pptx
+++ b/presentation/Playwright_CLI.pptx
@@ -10,9 +10,14 @@
     <p:sldId id="258" r:id="rId4"/>
     <p:sldId id="261" r:id="rId5"/>
     <p:sldId id="259" r:id="rId6"/>
-    <p:sldId id="260" r:id="rId7"/>
-    <p:sldId id="262" r:id="rId8"/>
-    <p:sldId id="263" r:id="rId9"/>
+    <p:sldId id="264" r:id="rId7"/>
+    <p:sldId id="260" r:id="rId8"/>
+    <p:sldId id="266" r:id="rId9"/>
+    <p:sldId id="267" r:id="rId10"/>
+    <p:sldId id="268" r:id="rId11"/>
+    <p:sldId id="265" r:id="rId12"/>
+    <p:sldId id="262" r:id="rId13"/>
+    <p:sldId id="263" r:id="rId14"/>
   </p:sldIdLst>
   <p:sldSz cx="12192000" cy="6858000"/>
   <p:notesSz cx="6858000" cy="9144000"/>
@@ -111,6 +116,11 @@
       </a:defRPr>
     </a:lvl9pPr>
   </p:defaultTextStyle>
+  <p:extLst>
+    <p:ext uri="{EFAFB233-063F-42B5-8137-9DF3F51BA10A}">
+      <p15:sldGuideLst xmlns:p15="http://schemas.microsoft.com/office/powerpoint/2012/main"/>
+    </p:ext>
+  </p:extLst>
 </p:presentation>
 </file>
 
@@ -261,7 +271,7 @@
           <a:p>
             <a:fld id="{80DC75B9-50B5-4816-B42B-6902F04D9BD5}" type="datetimeFigureOut">
               <a:rPr lang="en-US" smtClean="0"/>
-              <a:t>3/3/2026</a:t>
+              <a:t>5/3/2026</a:t>
             </a:fld>
             <a:endParaRPr lang="en-US"/>
           </a:p>
@@ -459,7 +469,7 @@
           <a:p>
             <a:fld id="{80DC75B9-50B5-4816-B42B-6902F04D9BD5}" type="datetimeFigureOut">
               <a:rPr lang="en-US" smtClean="0"/>
-              <a:t>3/3/2026</a:t>
+              <a:t>5/3/2026</a:t>
             </a:fld>
             <a:endParaRPr lang="en-US"/>
           </a:p>
@@ -667,7 +677,7 @@
           <a:p>
             <a:fld id="{80DC75B9-50B5-4816-B42B-6902F04D9BD5}" type="datetimeFigureOut">
               <a:rPr lang="en-US" smtClean="0"/>
-              <a:t>3/3/2026</a:t>
+              <a:t>5/3/2026</a:t>
             </a:fld>
             <a:endParaRPr lang="en-US"/>
           </a:p>
@@ -865,7 +875,7 @@
           <a:p>
             <a:fld id="{80DC75B9-50B5-4816-B42B-6902F04D9BD5}" type="datetimeFigureOut">
               <a:rPr lang="en-US" smtClean="0"/>
-              <a:t>3/3/2026</a:t>
+              <a:t>5/3/2026</a:t>
             </a:fld>
             <a:endParaRPr lang="en-US"/>
           </a:p>
@@ -1140,7 +1150,7 @@
           <a:p>
             <a:fld id="{80DC75B9-50B5-4816-B42B-6902F04D9BD5}" type="datetimeFigureOut">
               <a:rPr lang="en-US" smtClean="0"/>
-              <a:t>3/3/2026</a:t>
+              <a:t>5/3/2026</a:t>
             </a:fld>
             <a:endParaRPr lang="en-US"/>
           </a:p>
@@ -1405,7 +1415,7 @@
           <a:p>
             <a:fld id="{80DC75B9-50B5-4816-B42B-6902F04D9BD5}" type="datetimeFigureOut">
               <a:rPr lang="en-US" smtClean="0"/>
-              <a:t>3/3/2026</a:t>
+              <a:t>5/3/2026</a:t>
             </a:fld>
             <a:endParaRPr lang="en-US"/>
           </a:p>
@@ -1817,7 +1827,7 @@
           <a:p>
             <a:fld id="{80DC75B9-50B5-4816-B42B-6902F04D9BD5}" type="datetimeFigureOut">
               <a:rPr lang="en-US" smtClean="0"/>
-              <a:t>3/3/2026</a:t>
+              <a:t>5/3/2026</a:t>
             </a:fld>
             <a:endParaRPr lang="en-US"/>
           </a:p>
@@ -1958,7 +1968,7 @@
           <a:p>
             <a:fld id="{80DC75B9-50B5-4816-B42B-6902F04D9BD5}" type="datetimeFigureOut">
               <a:rPr lang="en-US" smtClean="0"/>
-              <a:t>3/3/2026</a:t>
+              <a:t>5/3/2026</a:t>
             </a:fld>
             <a:endParaRPr lang="en-US"/>
           </a:p>
@@ -2071,7 +2081,7 @@
           <a:p>
             <a:fld id="{80DC75B9-50B5-4816-B42B-6902F04D9BD5}" type="datetimeFigureOut">
               <a:rPr lang="en-US" smtClean="0"/>
-              <a:t>3/3/2026</a:t>
+              <a:t>5/3/2026</a:t>
             </a:fld>
             <a:endParaRPr lang="en-US"/>
           </a:p>
@@ -2382,7 +2392,7 @@
           <a:p>
             <a:fld id="{80DC75B9-50B5-4816-B42B-6902F04D9BD5}" type="datetimeFigureOut">
               <a:rPr lang="en-US" smtClean="0"/>
-              <a:t>3/3/2026</a:t>
+              <a:t>5/3/2026</a:t>
             </a:fld>
             <a:endParaRPr lang="en-US"/>
           </a:p>
@@ -2670,7 +2680,7 @@
           <a:p>
             <a:fld id="{80DC75B9-50B5-4816-B42B-6902F04D9BD5}" type="datetimeFigureOut">
               <a:rPr lang="en-US" smtClean="0"/>
-              <a:t>3/3/2026</a:t>
+              <a:t>5/3/2026</a:t>
             </a:fld>
             <a:endParaRPr lang="en-US"/>
           </a:p>
@@ -2911,7 +2921,7 @@
           <a:p>
             <a:fld id="{80DC75B9-50B5-4816-B42B-6902F04D9BD5}" type="datetimeFigureOut">
               <a:rPr lang="en-US" smtClean="0"/>
-              <a:t>3/3/2026</a:t>
+              <a:t>5/3/2026</a:t>
             </a:fld>
             <a:endParaRPr lang="en-US"/>
           </a:p>
@@ -3399,6 +3409,409 @@
 </p:sld>
 </file>
 
+<file path=ppt/slides/slide10.xml><?xml version="1.0" encoding="utf-8"?>
+<p:sld xmlns:a="http://schemas.openxmlformats.org/drawingml/2006/main" xmlns:r="http://schemas.openxmlformats.org/officeDocument/2006/relationships" xmlns:p="http://schemas.openxmlformats.org/presentationml/2006/main">
+  <p:cSld>
+    <p:spTree>
+      <p:nvGrpSpPr>
+        <p:cNvPr id="1" name=""/>
+        <p:cNvGrpSpPr/>
+        <p:nvPr/>
+      </p:nvGrpSpPr>
+      <p:grpSpPr>
+        <a:xfrm>
+          <a:off x="0" y="0"/>
+          <a:ext cx="0" cy="0"/>
+          <a:chOff x="0" y="0"/>
+          <a:chExt cx="0" cy="0"/>
+        </a:xfrm>
+      </p:grpSpPr>
+      <p:sp>
+        <p:nvSpPr>
+          <p:cNvPr id="2" name="Title 1">
+            <a:extLst>
+              <a:ext uri="{FF2B5EF4-FFF2-40B4-BE49-F238E27FC236}">
+                <a16:creationId xmlns:a16="http://schemas.microsoft.com/office/drawing/2014/main" id="{A8577F9C-A994-0265-E0F9-784BB0E3CC51}"/>
+              </a:ext>
+            </a:extLst>
+          </p:cNvPr>
+          <p:cNvSpPr>
+            <a:spLocks noGrp="1"/>
+          </p:cNvSpPr>
+          <p:nvPr>
+            <p:ph type="title"/>
+          </p:nvPr>
+        </p:nvSpPr>
+        <p:spPr/>
+        <p:txBody>
+          <a:bodyPr/>
+          <a:lstStyle/>
+          <a:p>
+            <a:endParaRPr lang="en-US"/>
+          </a:p>
+        </p:txBody>
+      </p:sp>
+      <p:sp>
+        <p:nvSpPr>
+          <p:cNvPr id="3" name="Content Placeholder 2">
+            <a:extLst>
+              <a:ext uri="{FF2B5EF4-FFF2-40B4-BE49-F238E27FC236}">
+                <a16:creationId xmlns:a16="http://schemas.microsoft.com/office/drawing/2014/main" id="{4CC2DE5C-1EFF-28EA-5F63-E4551BE9EBF8}"/>
+              </a:ext>
+            </a:extLst>
+          </p:cNvPr>
+          <p:cNvSpPr>
+            <a:spLocks noGrp="1"/>
+          </p:cNvSpPr>
+          <p:nvPr>
+            <p:ph idx="1"/>
+          </p:nvPr>
+        </p:nvSpPr>
+        <p:spPr/>
+        <p:txBody>
+          <a:bodyPr/>
+          <a:lstStyle/>
+          <a:p>
+            <a:endParaRPr lang="en-US"/>
+          </a:p>
+        </p:txBody>
+      </p:sp>
+      <p:pic>
+        <p:nvPicPr>
+          <p:cNvPr id="5" name="Picture 4">
+            <a:extLst>
+              <a:ext uri="{FF2B5EF4-FFF2-40B4-BE49-F238E27FC236}">
+                <a16:creationId xmlns:a16="http://schemas.microsoft.com/office/drawing/2014/main" id="{354642D7-6F96-97C0-188F-B79F85F3CB03}"/>
+              </a:ext>
+            </a:extLst>
+          </p:cNvPr>
+          <p:cNvPicPr>
+            <a:picLocks noChangeAspect="1"/>
+          </p:cNvPicPr>
+          <p:nvPr/>
+        </p:nvPicPr>
+        <p:blipFill>
+          <a:blip r:embed="rId2"/>
+          <a:stretch>
+            <a:fillRect/>
+          </a:stretch>
+        </p:blipFill>
+        <p:spPr>
+          <a:xfrm>
+            <a:off x="823176" y="485364"/>
+            <a:ext cx="10545647" cy="5887272"/>
+          </a:xfrm>
+          <a:prstGeom prst="rect">
+            <a:avLst/>
+          </a:prstGeom>
+        </p:spPr>
+      </p:pic>
+    </p:spTree>
+    <p:extLst>
+      <p:ext uri="{BB962C8B-B14F-4D97-AF65-F5344CB8AC3E}">
+        <p14:creationId xmlns:p14="http://schemas.microsoft.com/office/powerpoint/2010/main" val="334675824"/>
+      </p:ext>
+    </p:extLst>
+  </p:cSld>
+  <p:clrMapOvr>
+    <a:masterClrMapping/>
+  </p:clrMapOvr>
+</p:sld>
+</file>
+
+<file path=ppt/slides/slide11.xml><?xml version="1.0" encoding="utf-8"?>
+<p:sld xmlns:a="http://schemas.openxmlformats.org/drawingml/2006/main" xmlns:r="http://schemas.openxmlformats.org/officeDocument/2006/relationships" xmlns:p="http://schemas.openxmlformats.org/presentationml/2006/main">
+  <p:cSld>
+    <p:spTree>
+      <p:nvGrpSpPr>
+        <p:cNvPr id="1" name=""/>
+        <p:cNvGrpSpPr/>
+        <p:nvPr/>
+      </p:nvGrpSpPr>
+      <p:grpSpPr>
+        <a:xfrm>
+          <a:off x="0" y="0"/>
+          <a:ext cx="0" cy="0"/>
+          <a:chOff x="0" y="0"/>
+          <a:chExt cx="0" cy="0"/>
+        </a:xfrm>
+      </p:grpSpPr>
+      <p:sp>
+        <p:nvSpPr>
+          <p:cNvPr id="2" name="Title 1">
+            <a:extLst>
+              <a:ext uri="{FF2B5EF4-FFF2-40B4-BE49-F238E27FC236}">
+                <a16:creationId xmlns:a16="http://schemas.microsoft.com/office/drawing/2014/main" id="{B92FEFE3-52E6-359C-5F9C-253975CB07F1}"/>
+              </a:ext>
+            </a:extLst>
+          </p:cNvPr>
+          <p:cNvSpPr>
+            <a:spLocks noGrp="1"/>
+          </p:cNvSpPr>
+          <p:nvPr>
+            <p:ph type="title"/>
+          </p:nvPr>
+        </p:nvSpPr>
+        <p:spPr/>
+        <p:txBody>
+          <a:bodyPr/>
+          <a:lstStyle/>
+          <a:p>
+            <a:endParaRPr lang="en-US"/>
+          </a:p>
+        </p:txBody>
+      </p:sp>
+      <p:sp>
+        <p:nvSpPr>
+          <p:cNvPr id="3" name="Content Placeholder 2">
+            <a:extLst>
+              <a:ext uri="{FF2B5EF4-FFF2-40B4-BE49-F238E27FC236}">
+                <a16:creationId xmlns:a16="http://schemas.microsoft.com/office/drawing/2014/main" id="{9008EF2C-092A-BA37-A600-FC84E20ACC95}"/>
+              </a:ext>
+            </a:extLst>
+          </p:cNvPr>
+          <p:cNvSpPr>
+            <a:spLocks noGrp="1"/>
+          </p:cNvSpPr>
+          <p:nvPr>
+            <p:ph idx="1"/>
+          </p:nvPr>
+        </p:nvSpPr>
+        <p:spPr/>
+        <p:txBody>
+          <a:bodyPr/>
+          <a:lstStyle/>
+          <a:p>
+            <a:endParaRPr lang="en-US"/>
+          </a:p>
+        </p:txBody>
+      </p:sp>
+      <p:pic>
+        <p:nvPicPr>
+          <p:cNvPr id="5" name="Picture 4">
+            <a:extLst>
+              <a:ext uri="{FF2B5EF4-FFF2-40B4-BE49-F238E27FC236}">
+                <a16:creationId xmlns:a16="http://schemas.microsoft.com/office/drawing/2014/main" id="{FCA00B15-E827-DCB1-3CE4-E20FE7DD640B}"/>
+              </a:ext>
+            </a:extLst>
+          </p:cNvPr>
+          <p:cNvPicPr>
+            <a:picLocks noChangeAspect="1"/>
+          </p:cNvPicPr>
+          <p:nvPr/>
+        </p:nvPicPr>
+        <p:blipFill>
+          <a:blip r:embed="rId2"/>
+          <a:stretch>
+            <a:fillRect/>
+          </a:stretch>
+        </p:blipFill>
+        <p:spPr>
+          <a:xfrm>
+            <a:off x="399255" y="123363"/>
+            <a:ext cx="11393490" cy="6611273"/>
+          </a:xfrm>
+          <a:prstGeom prst="rect">
+            <a:avLst/>
+          </a:prstGeom>
+        </p:spPr>
+      </p:pic>
+    </p:spTree>
+    <p:extLst>
+      <p:ext uri="{BB962C8B-B14F-4D97-AF65-F5344CB8AC3E}">
+        <p14:creationId xmlns:p14="http://schemas.microsoft.com/office/powerpoint/2010/main" val="2061693886"/>
+      </p:ext>
+    </p:extLst>
+  </p:cSld>
+  <p:clrMapOvr>
+    <a:masterClrMapping/>
+  </p:clrMapOvr>
+</p:sld>
+</file>
+
+<file path=ppt/slides/slide12.xml><?xml version="1.0" encoding="utf-8"?>
+<p:sld xmlns:a="http://schemas.openxmlformats.org/drawingml/2006/main" xmlns:r="http://schemas.openxmlformats.org/officeDocument/2006/relationships" xmlns:p="http://schemas.openxmlformats.org/presentationml/2006/main">
+  <p:cSld>
+    <p:spTree>
+      <p:nvGrpSpPr>
+        <p:cNvPr id="1" name=""/>
+        <p:cNvGrpSpPr/>
+        <p:nvPr/>
+      </p:nvGrpSpPr>
+      <p:grpSpPr>
+        <a:xfrm>
+          <a:off x="0" y="0"/>
+          <a:ext cx="0" cy="0"/>
+          <a:chOff x="0" y="0"/>
+          <a:chExt cx="0" cy="0"/>
+        </a:xfrm>
+      </p:grpSpPr>
+      <p:sp>
+        <p:nvSpPr>
+          <p:cNvPr id="2" name="Title 1">
+            <a:extLst>
+              <a:ext uri="{FF2B5EF4-FFF2-40B4-BE49-F238E27FC236}">
+                <a16:creationId xmlns:a16="http://schemas.microsoft.com/office/drawing/2014/main" id="{CA2BA479-BF58-78C2-EA35-480ED8E11442}"/>
+              </a:ext>
+            </a:extLst>
+          </p:cNvPr>
+          <p:cNvSpPr>
+            <a:spLocks noGrp="1"/>
+          </p:cNvSpPr>
+          <p:nvPr>
+            <p:ph type="title"/>
+          </p:nvPr>
+        </p:nvSpPr>
+        <p:spPr/>
+        <p:txBody>
+          <a:bodyPr/>
+          <a:lstStyle/>
+          <a:p>
+            <a:r>
+              <a:rPr lang="en-IN" dirty="0"/>
+              <a:t>Trace </a:t>
+            </a:r>
+            <a:endParaRPr lang="en-US" dirty="0"/>
+          </a:p>
+        </p:txBody>
+      </p:sp>
+      <p:sp>
+        <p:nvSpPr>
+          <p:cNvPr id="3" name="Content Placeholder 2">
+            <a:extLst>
+              <a:ext uri="{FF2B5EF4-FFF2-40B4-BE49-F238E27FC236}">
+                <a16:creationId xmlns:a16="http://schemas.microsoft.com/office/drawing/2014/main" id="{CDCAC73C-13D5-72BF-A3E2-343C3D7CFE0C}"/>
+              </a:ext>
+            </a:extLst>
+          </p:cNvPr>
+          <p:cNvSpPr>
+            <a:spLocks noGrp="1"/>
+          </p:cNvSpPr>
+          <p:nvPr>
+            <p:ph idx="1"/>
+          </p:nvPr>
+        </p:nvSpPr>
+        <p:spPr/>
+        <p:txBody>
+          <a:bodyPr/>
+          <a:lstStyle/>
+          <a:p>
+            <a:r>
+              <a:rPr lang="en-IN" dirty="0"/>
+              <a:t>For previous prompt, record a trace with screenshots=true, snapshots=true, save as trace.zip</a:t>
+            </a:r>
+          </a:p>
+          <a:p>
+            <a:endParaRPr lang="en-IN" dirty="0"/>
+          </a:p>
+          <a:p>
+            <a:r>
+              <a:rPr lang="en-IN" dirty="0" err="1"/>
+              <a:t>npx</a:t>
+            </a:r>
+            <a:r>
+              <a:rPr lang="en-IN" dirty="0"/>
+              <a:t> playwright show-trace trace.zip</a:t>
+            </a:r>
+          </a:p>
+          <a:p>
+            <a:endParaRPr lang="en-US" dirty="0"/>
+          </a:p>
+        </p:txBody>
+      </p:sp>
+    </p:spTree>
+    <p:extLst>
+      <p:ext uri="{BB962C8B-B14F-4D97-AF65-F5344CB8AC3E}">
+        <p14:creationId xmlns:p14="http://schemas.microsoft.com/office/powerpoint/2010/main" val="1018747115"/>
+      </p:ext>
+    </p:extLst>
+  </p:cSld>
+  <p:clrMapOvr>
+    <a:masterClrMapping/>
+  </p:clrMapOvr>
+</p:sld>
+</file>
+
+<file path=ppt/slides/slide13.xml><?xml version="1.0" encoding="utf-8"?>
+<p:sld xmlns:a="http://schemas.openxmlformats.org/drawingml/2006/main" xmlns:r="http://schemas.openxmlformats.org/officeDocument/2006/relationships" xmlns:p="http://schemas.openxmlformats.org/presentationml/2006/main">
+  <p:cSld>
+    <p:spTree>
+      <p:nvGrpSpPr>
+        <p:cNvPr id="1" name=""/>
+        <p:cNvGrpSpPr/>
+        <p:nvPr/>
+      </p:nvGrpSpPr>
+      <p:grpSpPr>
+        <a:xfrm>
+          <a:off x="0" y="0"/>
+          <a:ext cx="0" cy="0"/>
+          <a:chOff x="0" y="0"/>
+          <a:chExt cx="0" cy="0"/>
+        </a:xfrm>
+      </p:grpSpPr>
+      <p:sp>
+        <p:nvSpPr>
+          <p:cNvPr id="2" name="Title 1">
+            <a:extLst>
+              <a:ext uri="{FF2B5EF4-FFF2-40B4-BE49-F238E27FC236}">
+                <a16:creationId xmlns:a16="http://schemas.microsoft.com/office/drawing/2014/main" id="{37A4B7A4-2130-F53B-67A7-0A35A6E793A5}"/>
+              </a:ext>
+            </a:extLst>
+          </p:cNvPr>
+          <p:cNvSpPr>
+            <a:spLocks noGrp="1"/>
+          </p:cNvSpPr>
+          <p:nvPr>
+            <p:ph type="title"/>
+          </p:nvPr>
+        </p:nvSpPr>
+        <p:spPr/>
+        <p:txBody>
+          <a:bodyPr/>
+          <a:lstStyle/>
+          <a:p>
+            <a:endParaRPr lang="en-US"/>
+          </a:p>
+        </p:txBody>
+      </p:sp>
+      <p:sp>
+        <p:nvSpPr>
+          <p:cNvPr id="3" name="Content Placeholder 2">
+            <a:extLst>
+              <a:ext uri="{FF2B5EF4-FFF2-40B4-BE49-F238E27FC236}">
+                <a16:creationId xmlns:a16="http://schemas.microsoft.com/office/drawing/2014/main" id="{E107189A-F7BB-5303-0D98-38630408498C}"/>
+              </a:ext>
+            </a:extLst>
+          </p:cNvPr>
+          <p:cNvSpPr>
+            <a:spLocks noGrp="1"/>
+          </p:cNvSpPr>
+          <p:nvPr>
+            <p:ph idx="1"/>
+          </p:nvPr>
+        </p:nvSpPr>
+        <p:spPr/>
+        <p:txBody>
+          <a:bodyPr/>
+          <a:lstStyle/>
+          <a:p>
+            <a:endParaRPr lang="en-US"/>
+          </a:p>
+        </p:txBody>
+      </p:sp>
+    </p:spTree>
+    <p:extLst>
+      <p:ext uri="{BB962C8B-B14F-4D97-AF65-F5344CB8AC3E}">
+        <p14:creationId xmlns:p14="http://schemas.microsoft.com/office/powerpoint/2010/main" val="3954423602"/>
+      </p:ext>
+    </p:extLst>
+  </p:cSld>
+  <p:clrMapOvr>
+    <a:masterClrMapping/>
+  </p:clrMapOvr>
+</p:sld>
+</file>
+
 <file path=ppt/slides/slide2.xml><?xml version="1.0" encoding="utf-8"?>
 <p:sld xmlns:a="http://schemas.openxmlformats.org/drawingml/2006/main" xmlns:r="http://schemas.openxmlformats.org/officeDocument/2006/relationships" xmlns:p="http://schemas.openxmlformats.org/presentationml/2006/main">
   <p:cSld>
@@ -3938,7 +4351,7 @@
           <p:cNvPr id="2" name="Title 1">
             <a:extLst>
               <a:ext uri="{FF2B5EF4-FFF2-40B4-BE49-F238E27FC236}">
-                <a16:creationId xmlns:a16="http://schemas.microsoft.com/office/drawing/2014/main" id="{9BEFB1F6-5C5F-C5D7-1650-A15544A55AD4}"/>
+                <a16:creationId xmlns:a16="http://schemas.microsoft.com/office/drawing/2014/main" id="{7BC37784-0778-D291-005C-6CB7D0773BA0}"/>
               </a:ext>
             </a:extLst>
           </p:cNvPr>
@@ -3954,11 +4367,7 @@
           <a:bodyPr/>
           <a:lstStyle/>
           <a:p>
-            <a:r>
-              <a:rPr lang="en-IN" dirty="0"/>
-              <a:t>Examples &amp; Prompts 	</a:t>
-            </a:r>
-            <a:endParaRPr lang="en-US" dirty="0"/>
+            <a:endParaRPr lang="en-US"/>
           </a:p>
         </p:txBody>
       </p:sp>
@@ -3967,7 +4376,7 @@
           <p:cNvPr id="3" name="Content Placeholder 2">
             <a:extLst>
               <a:ext uri="{FF2B5EF4-FFF2-40B4-BE49-F238E27FC236}">
-                <a16:creationId xmlns:a16="http://schemas.microsoft.com/office/drawing/2014/main" id="{4621E592-4ECB-4869-2878-E9F2146385F0}"/>
+                <a16:creationId xmlns:a16="http://schemas.microsoft.com/office/drawing/2014/main" id="{260882CB-CB29-4567-F873-51A433AE5EA3}"/>
               </a:ext>
             </a:extLst>
           </p:cNvPr>
@@ -3983,44 +4392,44 @@
           <a:bodyPr/>
           <a:lstStyle/>
           <a:p>
-            <a:r>
-              <a:rPr lang="en-IN" dirty="0"/>
-              <a:t>Use Playwright cli, </a:t>
-            </a:r>
-            <a:r>
-              <a:rPr lang="en-IN" dirty="0" err="1"/>
-              <a:t>goto</a:t>
-            </a:r>
-            <a:r>
-              <a:rPr lang="en-IN" dirty="0"/>
-              <a:t> website </a:t>
-            </a:r>
-            <a:r>
-              <a:rPr lang="en-IN" dirty="0">
-                <a:hlinkClick r:id="rId2"/>
-              </a:rPr>
-              <a:t>www.saucedemo.com</a:t>
-            </a:r>
-            <a:r>
-              <a:rPr lang="en-IN" dirty="0"/>
-              <a:t> , login with existing credentials. Complete the checkout process. </a:t>
-            </a:r>
-          </a:p>
-          <a:p>
-            <a:r>
-              <a:rPr lang="en-IN" dirty="0"/>
-              <a:t>Record a video, save it using –filename=demo.mp4</a:t>
-            </a:r>
-          </a:p>
-          <a:p>
-            <a:endParaRPr lang="en-US" dirty="0"/>
-          </a:p>
-        </p:txBody>
-      </p:sp>
+            <a:endParaRPr lang="en-US"/>
+          </a:p>
+        </p:txBody>
+      </p:sp>
+      <p:pic>
+        <p:nvPicPr>
+          <p:cNvPr id="5" name="Picture 4">
+            <a:extLst>
+              <a:ext uri="{FF2B5EF4-FFF2-40B4-BE49-F238E27FC236}">
+                <a16:creationId xmlns:a16="http://schemas.microsoft.com/office/drawing/2014/main" id="{42BF78B5-D94B-6E8B-4264-9E978C254A5B}"/>
+              </a:ext>
+            </a:extLst>
+          </p:cNvPr>
+          <p:cNvPicPr>
+            <a:picLocks noChangeAspect="1"/>
+          </p:cNvPicPr>
+          <p:nvPr/>
+        </p:nvPicPr>
+        <p:blipFill>
+          <a:blip r:embed="rId2"/>
+          <a:stretch>
+            <a:fillRect/>
+          </a:stretch>
+        </p:blipFill>
+        <p:spPr>
+          <a:xfrm>
+            <a:off x="0" y="927046"/>
+            <a:ext cx="12192000" cy="5003907"/>
+          </a:xfrm>
+          <a:prstGeom prst="rect">
+            <a:avLst/>
+          </a:prstGeom>
+        </p:spPr>
+      </p:pic>
     </p:spTree>
     <p:extLst>
       <p:ext uri="{BB962C8B-B14F-4D97-AF65-F5344CB8AC3E}">
-        <p14:creationId xmlns:p14="http://schemas.microsoft.com/office/powerpoint/2010/main" val="2896553694"/>
+        <p14:creationId xmlns:p14="http://schemas.microsoft.com/office/powerpoint/2010/main" val="1277252323"/>
       </p:ext>
     </p:extLst>
   </p:cSld>
@@ -4052,7 +4461,7 @@
           <p:cNvPr id="2" name="Title 1">
             <a:extLst>
               <a:ext uri="{FF2B5EF4-FFF2-40B4-BE49-F238E27FC236}">
-                <a16:creationId xmlns:a16="http://schemas.microsoft.com/office/drawing/2014/main" id="{CA2BA479-BF58-78C2-EA35-480ED8E11442}"/>
+                <a16:creationId xmlns:a16="http://schemas.microsoft.com/office/drawing/2014/main" id="{9BEFB1F6-5C5F-C5D7-1650-A15544A55AD4}"/>
               </a:ext>
             </a:extLst>
           </p:cNvPr>
@@ -4070,7 +4479,7 @@
           <a:p>
             <a:r>
               <a:rPr lang="en-IN" dirty="0"/>
-              <a:t>Trace </a:t>
+              <a:t>Examples &amp; Prompts 	</a:t>
             </a:r>
             <a:endParaRPr lang="en-US" dirty="0"/>
           </a:p>
@@ -4081,7 +4490,7 @@
           <p:cNvPr id="3" name="Content Placeholder 2">
             <a:extLst>
               <a:ext uri="{FF2B5EF4-FFF2-40B4-BE49-F238E27FC236}">
-                <a16:creationId xmlns:a16="http://schemas.microsoft.com/office/drawing/2014/main" id="{CDCAC73C-13D5-72BF-A3E2-343C3D7CFE0C}"/>
+                <a16:creationId xmlns:a16="http://schemas.microsoft.com/office/drawing/2014/main" id="{4621E592-4ECB-4869-2878-E9F2146385F0}"/>
               </a:ext>
             </a:extLst>
           </p:cNvPr>
@@ -4099,21 +4508,55 @@
           <a:p>
             <a:r>
               <a:rPr lang="en-IN" dirty="0"/>
-              <a:t>For previous prompt, record a trace with screenshots=true, snapshots=true, save as trace.zip</a:t>
-            </a:r>
-          </a:p>
-          <a:p>
+              <a:t>Use Playwright cli, </a:t>
+            </a:r>
+            <a:r>
+              <a:rPr lang="en-IN" dirty="0" err="1"/>
+              <a:t>goto</a:t>
+            </a:r>
+            <a:r>
+              <a:rPr lang="en-IN" dirty="0"/>
+              <a:t> website </a:t>
+            </a:r>
+            <a:r>
+              <a:rPr lang="en-IN" dirty="0">
+                <a:hlinkClick r:id="rId2"/>
+              </a:rPr>
+              <a:t>www.saucedemo.com</a:t>
+            </a:r>
+            <a:r>
+              <a:rPr lang="en-IN" dirty="0"/>
+              <a:t> , login with existing credentials. Complete the checkout process. </a:t>
+            </a:r>
+          </a:p>
+          <a:p>
+            <a:r>
+              <a:rPr lang="en-IN" dirty="0"/>
+              <a:t>Record a video, save it using –filename=demo.mp4</a:t>
+            </a:r>
+          </a:p>
+          <a:p>
+            <a:r>
+              <a:rPr lang="en-GB" dirty="0"/>
+              <a:t> can you make a test plan</a:t>
+            </a:r>
+            <a:r>
+              <a:rPr lang="en-IN" dirty="0"/>
+              <a:t> &amp; </a:t>
+            </a:r>
+            <a:r>
+              <a:rPr lang="en-GB" dirty="0"/>
+              <a:t> save the plan.md </a:t>
+            </a:r>
+            <a:r>
+              <a:rPr lang="en-GB"/>
+              <a:t>file in </a:t>
+            </a:r>
+            <a:r>
+              <a:rPr lang="en-GB" dirty="0"/>
+              <a:t>this repo</a:t>
+            </a:r>
             <a:endParaRPr lang="en-IN" dirty="0"/>
-          </a:p>
-          <a:p>
-            <a:r>
-              <a:rPr lang="en-IN" dirty="0" err="1"/>
-              <a:t>npx</a:t>
-            </a:r>
-            <a:r>
-              <a:rPr lang="en-IN" dirty="0"/>
-              <a:t> playwright show-trace trace.zip</a:t>
-            </a:r>
           </a:p>
           <a:p>
             <a:endParaRPr lang="en-US" dirty="0"/>
@@ -4123,7 +4566,7 @@
     </p:spTree>
     <p:extLst>
       <p:ext uri="{BB962C8B-B14F-4D97-AF65-F5344CB8AC3E}">
-        <p14:creationId xmlns:p14="http://schemas.microsoft.com/office/powerpoint/2010/main" val="1018747115"/>
+        <p14:creationId xmlns:p14="http://schemas.microsoft.com/office/powerpoint/2010/main" val="2896553694"/>
       </p:ext>
     </p:extLst>
   </p:cSld>
@@ -4155,7 +4598,7 @@
           <p:cNvPr id="2" name="Title 1">
             <a:extLst>
               <a:ext uri="{FF2B5EF4-FFF2-40B4-BE49-F238E27FC236}">
-                <a16:creationId xmlns:a16="http://schemas.microsoft.com/office/drawing/2014/main" id="{37A4B7A4-2130-F53B-67A7-0A35A6E793A5}"/>
+                <a16:creationId xmlns:a16="http://schemas.microsoft.com/office/drawing/2014/main" id="{D182E778-C29C-4AF0-C3CA-1B399A6DD3CF}"/>
               </a:ext>
             </a:extLst>
           </p:cNvPr>
@@ -4180,7 +4623,7 @@
           <p:cNvPr id="3" name="Content Placeholder 2">
             <a:extLst>
               <a:ext uri="{FF2B5EF4-FFF2-40B4-BE49-F238E27FC236}">
-                <a16:creationId xmlns:a16="http://schemas.microsoft.com/office/drawing/2014/main" id="{E107189A-F7BB-5303-0D98-38630408498C}"/>
+                <a16:creationId xmlns:a16="http://schemas.microsoft.com/office/drawing/2014/main" id="{44C1C09A-C471-D30C-2C45-7A56EA6EF03E}"/>
               </a:ext>
             </a:extLst>
           </p:cNvPr>
@@ -4200,10 +4643,150 @@
           </a:p>
         </p:txBody>
       </p:sp>
+      <p:pic>
+        <p:nvPicPr>
+          <p:cNvPr id="5" name="Picture 4">
+            <a:extLst>
+              <a:ext uri="{FF2B5EF4-FFF2-40B4-BE49-F238E27FC236}">
+                <a16:creationId xmlns:a16="http://schemas.microsoft.com/office/drawing/2014/main" id="{0EFC1215-187D-DE46-1544-9D236846B0AF}"/>
+              </a:ext>
+            </a:extLst>
+          </p:cNvPr>
+          <p:cNvPicPr>
+            <a:picLocks noChangeAspect="1"/>
+          </p:cNvPicPr>
+          <p:nvPr/>
+        </p:nvPicPr>
+        <p:blipFill>
+          <a:blip r:embed="rId2"/>
+          <a:stretch>
+            <a:fillRect/>
+          </a:stretch>
+        </p:blipFill>
+        <p:spPr>
+          <a:xfrm>
+            <a:off x="1631396" y="0"/>
+            <a:ext cx="8929207" cy="6858000"/>
+          </a:xfrm>
+          <a:prstGeom prst="rect">
+            <a:avLst/>
+          </a:prstGeom>
+        </p:spPr>
+      </p:pic>
     </p:spTree>
     <p:extLst>
       <p:ext uri="{BB962C8B-B14F-4D97-AF65-F5344CB8AC3E}">
-        <p14:creationId xmlns:p14="http://schemas.microsoft.com/office/powerpoint/2010/main" val="3954423602"/>
+        <p14:creationId xmlns:p14="http://schemas.microsoft.com/office/powerpoint/2010/main" val="2564279772"/>
+      </p:ext>
+    </p:extLst>
+  </p:cSld>
+  <p:clrMapOvr>
+    <a:masterClrMapping/>
+  </p:clrMapOvr>
+</p:sld>
+</file>
+
+<file path=ppt/slides/slide9.xml><?xml version="1.0" encoding="utf-8"?>
+<p:sld xmlns:a="http://schemas.openxmlformats.org/drawingml/2006/main" xmlns:r="http://schemas.openxmlformats.org/officeDocument/2006/relationships" xmlns:p="http://schemas.openxmlformats.org/presentationml/2006/main">
+  <p:cSld>
+    <p:spTree>
+      <p:nvGrpSpPr>
+        <p:cNvPr id="1" name=""/>
+        <p:cNvGrpSpPr/>
+        <p:nvPr/>
+      </p:nvGrpSpPr>
+      <p:grpSpPr>
+        <a:xfrm>
+          <a:off x="0" y="0"/>
+          <a:ext cx="0" cy="0"/>
+          <a:chOff x="0" y="0"/>
+          <a:chExt cx="0" cy="0"/>
+        </a:xfrm>
+      </p:grpSpPr>
+      <p:sp>
+        <p:nvSpPr>
+          <p:cNvPr id="2" name="Title 1">
+            <a:extLst>
+              <a:ext uri="{FF2B5EF4-FFF2-40B4-BE49-F238E27FC236}">
+                <a16:creationId xmlns:a16="http://schemas.microsoft.com/office/drawing/2014/main" id="{6E4B2A3D-150A-C33B-7CAA-693BA1524FEB}"/>
+              </a:ext>
+            </a:extLst>
+          </p:cNvPr>
+          <p:cNvSpPr>
+            <a:spLocks noGrp="1"/>
+          </p:cNvSpPr>
+          <p:nvPr>
+            <p:ph type="title"/>
+          </p:nvPr>
+        </p:nvSpPr>
+        <p:spPr/>
+        <p:txBody>
+          <a:bodyPr/>
+          <a:lstStyle/>
+          <a:p>
+            <a:endParaRPr lang="en-US"/>
+          </a:p>
+        </p:txBody>
+      </p:sp>
+      <p:sp>
+        <p:nvSpPr>
+          <p:cNvPr id="3" name="Content Placeholder 2">
+            <a:extLst>
+              <a:ext uri="{FF2B5EF4-FFF2-40B4-BE49-F238E27FC236}">
+                <a16:creationId xmlns:a16="http://schemas.microsoft.com/office/drawing/2014/main" id="{CE3321AD-DC6D-A7B9-B806-1DDEF2DD5759}"/>
+              </a:ext>
+            </a:extLst>
+          </p:cNvPr>
+          <p:cNvSpPr>
+            <a:spLocks noGrp="1"/>
+          </p:cNvSpPr>
+          <p:nvPr>
+            <p:ph idx="1"/>
+          </p:nvPr>
+        </p:nvSpPr>
+        <p:spPr/>
+        <p:txBody>
+          <a:bodyPr/>
+          <a:lstStyle/>
+          <a:p>
+            <a:endParaRPr lang="en-US"/>
+          </a:p>
+        </p:txBody>
+      </p:sp>
+      <p:pic>
+        <p:nvPicPr>
+          <p:cNvPr id="5" name="Picture 4">
+            <a:extLst>
+              <a:ext uri="{FF2B5EF4-FFF2-40B4-BE49-F238E27FC236}">
+                <a16:creationId xmlns:a16="http://schemas.microsoft.com/office/drawing/2014/main" id="{9256D8E3-8B64-4706-C123-9CB6786DE4F4}"/>
+              </a:ext>
+            </a:extLst>
+          </p:cNvPr>
+          <p:cNvPicPr>
+            <a:picLocks noChangeAspect="1"/>
+          </p:cNvPicPr>
+          <p:nvPr/>
+        </p:nvPicPr>
+        <p:blipFill>
+          <a:blip r:embed="rId2"/>
+          <a:stretch>
+            <a:fillRect/>
+          </a:stretch>
+        </p:blipFill>
+        <p:spPr>
+          <a:xfrm>
+            <a:off x="625678" y="0"/>
+            <a:ext cx="10940643" cy="6858000"/>
+          </a:xfrm>
+          <a:prstGeom prst="rect">
+            <a:avLst/>
+          </a:prstGeom>
+        </p:spPr>
+      </p:pic>
+    </p:spTree>
+    <p:extLst>
+      <p:ext uri="{BB962C8B-B14F-4D97-AF65-F5344CB8AC3E}">
+        <p14:creationId xmlns:p14="http://schemas.microsoft.com/office/powerpoint/2010/main" val="2782608260"/>
       </p:ext>
     </p:extLst>
   </p:cSld>

</xml_diff>

<commit_message>
PW-CLI website explored, test_plan created
</commit_message>
<xml_diff>
--- a/presentation/Playwright_CLI.pptx
+++ b/presentation/Playwright_CLI.pptx
@@ -16,10 +16,12 @@
     <p:sldId id="267" r:id="rId10"/>
     <p:sldId id="268" r:id="rId11"/>
     <p:sldId id="270" r:id="rId12"/>
-    <p:sldId id="265" r:id="rId13"/>
-    <p:sldId id="269" r:id="rId14"/>
-    <p:sldId id="262" r:id="rId15"/>
-    <p:sldId id="263" r:id="rId16"/>
+    <p:sldId id="271" r:id="rId13"/>
+    <p:sldId id="272" r:id="rId14"/>
+    <p:sldId id="265" r:id="rId15"/>
+    <p:sldId id="269" r:id="rId16"/>
+    <p:sldId id="262" r:id="rId17"/>
+    <p:sldId id="263" r:id="rId18"/>
   </p:sldIdLst>
   <p:sldSz cx="12192000" cy="6858000"/>
   <p:notesSz cx="6858000" cy="9144000"/>
@@ -3653,6 +3655,226 @@
           <p:cNvPr id="2" name="Title 1">
             <a:extLst>
               <a:ext uri="{FF2B5EF4-FFF2-40B4-BE49-F238E27FC236}">
+                <a16:creationId xmlns:a16="http://schemas.microsoft.com/office/drawing/2014/main" id="{BE5144C2-6FBD-EAB0-BFE1-5F43BCC848F2}"/>
+              </a:ext>
+            </a:extLst>
+          </p:cNvPr>
+          <p:cNvSpPr>
+            <a:spLocks noGrp="1"/>
+          </p:cNvSpPr>
+          <p:nvPr>
+            <p:ph type="title"/>
+          </p:nvPr>
+        </p:nvSpPr>
+        <p:spPr/>
+        <p:txBody>
+          <a:bodyPr/>
+          <a:lstStyle/>
+          <a:p>
+            <a:endParaRPr lang="en-US"/>
+          </a:p>
+        </p:txBody>
+      </p:sp>
+      <p:sp>
+        <p:nvSpPr>
+          <p:cNvPr id="3" name="Content Placeholder 2">
+            <a:extLst>
+              <a:ext uri="{FF2B5EF4-FFF2-40B4-BE49-F238E27FC236}">
+                <a16:creationId xmlns:a16="http://schemas.microsoft.com/office/drawing/2014/main" id="{7164E9BA-0227-190C-0C54-EC2F5D705386}"/>
+              </a:ext>
+            </a:extLst>
+          </p:cNvPr>
+          <p:cNvSpPr>
+            <a:spLocks noGrp="1"/>
+          </p:cNvSpPr>
+          <p:nvPr>
+            <p:ph idx="1"/>
+          </p:nvPr>
+        </p:nvSpPr>
+        <p:spPr/>
+        <p:txBody>
+          <a:bodyPr/>
+          <a:lstStyle/>
+          <a:p>
+            <a:endParaRPr lang="en-US"/>
+          </a:p>
+        </p:txBody>
+      </p:sp>
+      <p:pic>
+        <p:nvPicPr>
+          <p:cNvPr id="5" name="Picture 4">
+            <a:extLst>
+              <a:ext uri="{FF2B5EF4-FFF2-40B4-BE49-F238E27FC236}">
+                <a16:creationId xmlns:a16="http://schemas.microsoft.com/office/drawing/2014/main" id="{E84891FB-2985-94E9-B6FE-DB6C08B31F63}"/>
+              </a:ext>
+            </a:extLst>
+          </p:cNvPr>
+          <p:cNvPicPr>
+            <a:picLocks noChangeAspect="1"/>
+          </p:cNvPicPr>
+          <p:nvPr/>
+        </p:nvPicPr>
+        <p:blipFill>
+          <a:blip r:embed="rId2"/>
+          <a:stretch>
+            <a:fillRect/>
+          </a:stretch>
+        </p:blipFill>
+        <p:spPr>
+          <a:xfrm>
+            <a:off x="879389" y="0"/>
+            <a:ext cx="4780352" cy="6858000"/>
+          </a:xfrm>
+          <a:prstGeom prst="rect">
+            <a:avLst/>
+          </a:prstGeom>
+        </p:spPr>
+      </p:pic>
+    </p:spTree>
+    <p:extLst>
+      <p:ext uri="{BB962C8B-B14F-4D97-AF65-F5344CB8AC3E}">
+        <p14:creationId xmlns:p14="http://schemas.microsoft.com/office/powerpoint/2010/main" val="750153433"/>
+      </p:ext>
+    </p:extLst>
+  </p:cSld>
+  <p:clrMapOvr>
+    <a:masterClrMapping/>
+  </p:clrMapOvr>
+</p:sld>
+</file>
+
+<file path=ppt/slides/slide13.xml><?xml version="1.0" encoding="utf-8"?>
+<p:sld xmlns:a="http://schemas.openxmlformats.org/drawingml/2006/main" xmlns:r="http://schemas.openxmlformats.org/officeDocument/2006/relationships" xmlns:p="http://schemas.openxmlformats.org/presentationml/2006/main">
+  <p:cSld>
+    <p:spTree>
+      <p:nvGrpSpPr>
+        <p:cNvPr id="1" name=""/>
+        <p:cNvGrpSpPr/>
+        <p:nvPr/>
+      </p:nvGrpSpPr>
+      <p:grpSpPr>
+        <a:xfrm>
+          <a:off x="0" y="0"/>
+          <a:ext cx="0" cy="0"/>
+          <a:chOff x="0" y="0"/>
+          <a:chExt cx="0" cy="0"/>
+        </a:xfrm>
+      </p:grpSpPr>
+      <p:sp>
+        <p:nvSpPr>
+          <p:cNvPr id="2" name="Title 1">
+            <a:extLst>
+              <a:ext uri="{FF2B5EF4-FFF2-40B4-BE49-F238E27FC236}">
+                <a16:creationId xmlns:a16="http://schemas.microsoft.com/office/drawing/2014/main" id="{7B4AEE6D-A3F1-E9E9-FF80-8F5B143F84BD}"/>
+              </a:ext>
+            </a:extLst>
+          </p:cNvPr>
+          <p:cNvSpPr>
+            <a:spLocks noGrp="1"/>
+          </p:cNvSpPr>
+          <p:nvPr>
+            <p:ph type="title"/>
+          </p:nvPr>
+        </p:nvSpPr>
+        <p:spPr/>
+        <p:txBody>
+          <a:bodyPr/>
+          <a:lstStyle/>
+          <a:p>
+            <a:endParaRPr lang="en-US"/>
+          </a:p>
+        </p:txBody>
+      </p:sp>
+      <p:sp>
+        <p:nvSpPr>
+          <p:cNvPr id="3" name="Content Placeholder 2">
+            <a:extLst>
+              <a:ext uri="{FF2B5EF4-FFF2-40B4-BE49-F238E27FC236}">
+                <a16:creationId xmlns:a16="http://schemas.microsoft.com/office/drawing/2014/main" id="{E226320A-54D1-9972-4571-829D88FDA8BB}"/>
+              </a:ext>
+            </a:extLst>
+          </p:cNvPr>
+          <p:cNvSpPr>
+            <a:spLocks noGrp="1"/>
+          </p:cNvSpPr>
+          <p:nvPr>
+            <p:ph idx="1"/>
+          </p:nvPr>
+        </p:nvSpPr>
+        <p:spPr/>
+        <p:txBody>
+          <a:bodyPr/>
+          <a:lstStyle/>
+          <a:p>
+            <a:endParaRPr lang="en-US"/>
+          </a:p>
+        </p:txBody>
+      </p:sp>
+      <p:pic>
+        <p:nvPicPr>
+          <p:cNvPr id="5" name="Picture 4">
+            <a:extLst>
+              <a:ext uri="{FF2B5EF4-FFF2-40B4-BE49-F238E27FC236}">
+                <a16:creationId xmlns:a16="http://schemas.microsoft.com/office/drawing/2014/main" id="{C2E0DF9D-146B-FD2F-7420-6A193569613F}"/>
+              </a:ext>
+            </a:extLst>
+          </p:cNvPr>
+          <p:cNvPicPr>
+            <a:picLocks noChangeAspect="1"/>
+          </p:cNvPicPr>
+          <p:nvPr/>
+        </p:nvPicPr>
+        <p:blipFill>
+          <a:blip r:embed="rId2"/>
+          <a:stretch>
+            <a:fillRect/>
+          </a:stretch>
+        </p:blipFill>
+        <p:spPr>
+          <a:xfrm>
+            <a:off x="2554069" y="0"/>
+            <a:ext cx="7083862" cy="6858000"/>
+          </a:xfrm>
+          <a:prstGeom prst="rect">
+            <a:avLst/>
+          </a:prstGeom>
+        </p:spPr>
+      </p:pic>
+    </p:spTree>
+    <p:extLst>
+      <p:ext uri="{BB962C8B-B14F-4D97-AF65-F5344CB8AC3E}">
+        <p14:creationId xmlns:p14="http://schemas.microsoft.com/office/powerpoint/2010/main" val="2622566794"/>
+      </p:ext>
+    </p:extLst>
+  </p:cSld>
+  <p:clrMapOvr>
+    <a:masterClrMapping/>
+  </p:clrMapOvr>
+</p:sld>
+</file>
+
+<file path=ppt/slides/slide14.xml><?xml version="1.0" encoding="utf-8"?>
+<p:sld xmlns:a="http://schemas.openxmlformats.org/drawingml/2006/main" xmlns:r="http://schemas.openxmlformats.org/officeDocument/2006/relationships" xmlns:p="http://schemas.openxmlformats.org/presentationml/2006/main">
+  <p:cSld>
+    <p:spTree>
+      <p:nvGrpSpPr>
+        <p:cNvPr id="1" name=""/>
+        <p:cNvGrpSpPr/>
+        <p:nvPr/>
+      </p:nvGrpSpPr>
+      <p:grpSpPr>
+        <a:xfrm>
+          <a:off x="0" y="0"/>
+          <a:ext cx="0" cy="0"/>
+          <a:chOff x="0" y="0"/>
+          <a:chExt cx="0" cy="0"/>
+        </a:xfrm>
+      </p:grpSpPr>
+      <p:sp>
+        <p:nvSpPr>
+          <p:cNvPr id="2" name="Title 1">
+            <a:extLst>
+              <a:ext uri="{FF2B5EF4-FFF2-40B4-BE49-F238E27FC236}">
                 <a16:creationId xmlns:a16="http://schemas.microsoft.com/office/drawing/2014/main" id="{B92FEFE3-52E6-359C-5F9C-253975CB07F1}"/>
               </a:ext>
             </a:extLst>
@@ -3741,7 +3963,7 @@
 </p:sld>
 </file>
 
-<file path=ppt/slides/slide13.xml><?xml version="1.0" encoding="utf-8"?>
+<file path=ppt/slides/slide15.xml><?xml version="1.0" encoding="utf-8"?>
 <p:sld xmlns:a="http://schemas.openxmlformats.org/drawingml/2006/main" xmlns:r="http://schemas.openxmlformats.org/officeDocument/2006/relationships" xmlns:p="http://schemas.openxmlformats.org/presentationml/2006/main">
   <p:cSld>
     <p:spTree>
@@ -3851,7 +4073,7 @@
 </p:sld>
 </file>
 
-<file path=ppt/slides/slide14.xml><?xml version="1.0" encoding="utf-8"?>
+<file path=ppt/slides/slide16.xml><?xml version="1.0" encoding="utf-8"?>
 <p:sld xmlns:a="http://schemas.openxmlformats.org/drawingml/2006/main" xmlns:r="http://schemas.openxmlformats.org/officeDocument/2006/relationships" xmlns:p="http://schemas.openxmlformats.org/presentationml/2006/main">
   <p:cSld>
     <p:spTree>
@@ -3954,7 +4176,7 @@
 </p:sld>
 </file>
 
-<file path=ppt/slides/slide15.xml><?xml version="1.0" encoding="utf-8"?>
+<file path=ppt/slides/slide17.xml><?xml version="1.0" encoding="utf-8"?>
 <p:sld xmlns:a="http://schemas.openxmlformats.org/drawingml/2006/main" xmlns:r="http://schemas.openxmlformats.org/officeDocument/2006/relationships" xmlns:p="http://schemas.openxmlformats.org/presentationml/2006/main">
   <p:cSld>
     <p:spTree>

</xml_diff>

<commit_message>
PW-CLI POM architecture implementation
</commit_message>
<xml_diff>
--- a/presentation/Playwright_CLI.pptx
+++ b/presentation/Playwright_CLI.pptx
@@ -12,16 +12,13 @@
     <p:sldId id="259" r:id="rId6"/>
     <p:sldId id="264" r:id="rId7"/>
     <p:sldId id="260" r:id="rId8"/>
-    <p:sldId id="266" r:id="rId9"/>
-    <p:sldId id="267" r:id="rId10"/>
-    <p:sldId id="268" r:id="rId11"/>
-    <p:sldId id="270" r:id="rId12"/>
-    <p:sldId id="271" r:id="rId13"/>
-    <p:sldId id="272" r:id="rId14"/>
-    <p:sldId id="265" r:id="rId15"/>
-    <p:sldId id="269" r:id="rId16"/>
-    <p:sldId id="262" r:id="rId17"/>
-    <p:sldId id="263" r:id="rId18"/>
+    <p:sldId id="270" r:id="rId9"/>
+    <p:sldId id="271" r:id="rId10"/>
+    <p:sldId id="272" r:id="rId11"/>
+    <p:sldId id="265" r:id="rId12"/>
+    <p:sldId id="269" r:id="rId13"/>
+    <p:sldId id="262" r:id="rId14"/>
+    <p:sldId id="263" r:id="rId15"/>
   </p:sldIdLst>
   <p:sldSz cx="12192000" cy="6858000"/>
   <p:notesSz cx="6858000" cy="9144000"/>
@@ -3435,7 +3432,7 @@
           <p:cNvPr id="2" name="Title 1">
             <a:extLst>
               <a:ext uri="{FF2B5EF4-FFF2-40B4-BE49-F238E27FC236}">
-                <a16:creationId xmlns:a16="http://schemas.microsoft.com/office/drawing/2014/main" id="{A8577F9C-A994-0265-E0F9-784BB0E3CC51}"/>
+                <a16:creationId xmlns:a16="http://schemas.microsoft.com/office/drawing/2014/main" id="{7B4AEE6D-A3F1-E9E9-FF80-8F5B143F84BD}"/>
               </a:ext>
             </a:extLst>
           </p:cNvPr>
@@ -3460,7 +3457,7 @@
           <p:cNvPr id="3" name="Content Placeholder 2">
             <a:extLst>
               <a:ext uri="{FF2B5EF4-FFF2-40B4-BE49-F238E27FC236}">
-                <a16:creationId xmlns:a16="http://schemas.microsoft.com/office/drawing/2014/main" id="{4CC2DE5C-1EFF-28EA-5F63-E4551BE9EBF8}"/>
+                <a16:creationId xmlns:a16="http://schemas.microsoft.com/office/drawing/2014/main" id="{E226320A-54D1-9972-4571-829D88FDA8BB}"/>
               </a:ext>
             </a:extLst>
           </p:cNvPr>
@@ -3476,337 +3473,7 @@
           <a:bodyPr/>
           <a:lstStyle/>
           <a:p>
-            <a:endParaRPr lang="en-US"/>
-          </a:p>
-        </p:txBody>
-      </p:sp>
-      <p:pic>
-        <p:nvPicPr>
-          <p:cNvPr id="5" name="Picture 4">
-            <a:extLst>
-              <a:ext uri="{FF2B5EF4-FFF2-40B4-BE49-F238E27FC236}">
-                <a16:creationId xmlns:a16="http://schemas.microsoft.com/office/drawing/2014/main" id="{354642D7-6F96-97C0-188F-B79F85F3CB03}"/>
-              </a:ext>
-            </a:extLst>
-          </p:cNvPr>
-          <p:cNvPicPr>
-            <a:picLocks noChangeAspect="1"/>
-          </p:cNvPicPr>
-          <p:nvPr/>
-        </p:nvPicPr>
-        <p:blipFill>
-          <a:blip r:embed="rId2"/>
-          <a:stretch>
-            <a:fillRect/>
-          </a:stretch>
-        </p:blipFill>
-        <p:spPr>
-          <a:xfrm>
-            <a:off x="823176" y="485364"/>
-            <a:ext cx="10545647" cy="5887272"/>
-          </a:xfrm>
-          <a:prstGeom prst="rect">
-            <a:avLst/>
-          </a:prstGeom>
-        </p:spPr>
-      </p:pic>
-    </p:spTree>
-    <p:extLst>
-      <p:ext uri="{BB962C8B-B14F-4D97-AF65-F5344CB8AC3E}">
-        <p14:creationId xmlns:p14="http://schemas.microsoft.com/office/powerpoint/2010/main" val="334675824"/>
-      </p:ext>
-    </p:extLst>
-  </p:cSld>
-  <p:clrMapOvr>
-    <a:masterClrMapping/>
-  </p:clrMapOvr>
-</p:sld>
-</file>
-
-<file path=ppt/slides/slide11.xml><?xml version="1.0" encoding="utf-8"?>
-<p:sld xmlns:a="http://schemas.openxmlformats.org/drawingml/2006/main" xmlns:r="http://schemas.openxmlformats.org/officeDocument/2006/relationships" xmlns:p="http://schemas.openxmlformats.org/presentationml/2006/main">
-  <p:cSld>
-    <p:spTree>
-      <p:nvGrpSpPr>
-        <p:cNvPr id="1" name=""/>
-        <p:cNvGrpSpPr/>
-        <p:nvPr/>
-      </p:nvGrpSpPr>
-      <p:grpSpPr>
-        <a:xfrm>
-          <a:off x="0" y="0"/>
-          <a:ext cx="0" cy="0"/>
-          <a:chOff x="0" y="0"/>
-          <a:chExt cx="0" cy="0"/>
-        </a:xfrm>
-      </p:grpSpPr>
-      <p:sp>
-        <p:nvSpPr>
-          <p:cNvPr id="2" name="Title 1">
-            <a:extLst>
-              <a:ext uri="{FF2B5EF4-FFF2-40B4-BE49-F238E27FC236}">
-                <a16:creationId xmlns:a16="http://schemas.microsoft.com/office/drawing/2014/main" id="{F2822B0E-0203-DA06-B708-B67B8EAF7F2A}"/>
-              </a:ext>
-            </a:extLst>
-          </p:cNvPr>
-          <p:cNvSpPr>
-            <a:spLocks noGrp="1"/>
-          </p:cNvSpPr>
-          <p:nvPr>
-            <p:ph type="title"/>
-          </p:nvPr>
-        </p:nvSpPr>
-        <p:spPr/>
-        <p:txBody>
-          <a:bodyPr/>
-          <a:lstStyle/>
-          <a:p>
-            <a:endParaRPr lang="en-US"/>
-          </a:p>
-        </p:txBody>
-      </p:sp>
-      <p:sp>
-        <p:nvSpPr>
-          <p:cNvPr id="3" name="Content Placeholder 2">
-            <a:extLst>
-              <a:ext uri="{FF2B5EF4-FFF2-40B4-BE49-F238E27FC236}">
-                <a16:creationId xmlns:a16="http://schemas.microsoft.com/office/drawing/2014/main" id="{A539C5AE-1CC4-6F46-3306-37B11EE86C0A}"/>
-              </a:ext>
-            </a:extLst>
-          </p:cNvPr>
-          <p:cNvSpPr>
-            <a:spLocks noGrp="1"/>
-          </p:cNvSpPr>
-          <p:nvPr>
-            <p:ph idx="1"/>
-          </p:nvPr>
-        </p:nvSpPr>
-        <p:spPr/>
-        <p:txBody>
-          <a:bodyPr/>
-          <a:lstStyle/>
-          <a:p>
-            <a:endParaRPr lang="en-US"/>
-          </a:p>
-        </p:txBody>
-      </p:sp>
-      <p:pic>
-        <p:nvPicPr>
-          <p:cNvPr id="5" name="Picture 4">
-            <a:extLst>
-              <a:ext uri="{FF2B5EF4-FFF2-40B4-BE49-F238E27FC236}">
-                <a16:creationId xmlns:a16="http://schemas.microsoft.com/office/drawing/2014/main" id="{8AB542F2-146E-FB9C-4763-825D600F61AD}"/>
-              </a:ext>
-            </a:extLst>
-          </p:cNvPr>
-          <p:cNvPicPr>
-            <a:picLocks noChangeAspect="1"/>
-          </p:cNvPicPr>
-          <p:nvPr/>
-        </p:nvPicPr>
-        <p:blipFill>
-          <a:blip r:embed="rId2"/>
-          <a:stretch>
-            <a:fillRect/>
-          </a:stretch>
-        </p:blipFill>
-        <p:spPr>
-          <a:xfrm>
-            <a:off x="84306" y="0"/>
-            <a:ext cx="12023387" cy="6858000"/>
-          </a:xfrm>
-          <a:prstGeom prst="rect">
-            <a:avLst/>
-          </a:prstGeom>
-        </p:spPr>
-      </p:pic>
-    </p:spTree>
-    <p:extLst>
-      <p:ext uri="{BB962C8B-B14F-4D97-AF65-F5344CB8AC3E}">
-        <p14:creationId xmlns:p14="http://schemas.microsoft.com/office/powerpoint/2010/main" val="1509795331"/>
-      </p:ext>
-    </p:extLst>
-  </p:cSld>
-  <p:clrMapOvr>
-    <a:masterClrMapping/>
-  </p:clrMapOvr>
-</p:sld>
-</file>
-
-<file path=ppt/slides/slide12.xml><?xml version="1.0" encoding="utf-8"?>
-<p:sld xmlns:a="http://schemas.openxmlformats.org/drawingml/2006/main" xmlns:r="http://schemas.openxmlformats.org/officeDocument/2006/relationships" xmlns:p="http://schemas.openxmlformats.org/presentationml/2006/main">
-  <p:cSld>
-    <p:spTree>
-      <p:nvGrpSpPr>
-        <p:cNvPr id="1" name=""/>
-        <p:cNvGrpSpPr/>
-        <p:nvPr/>
-      </p:nvGrpSpPr>
-      <p:grpSpPr>
-        <a:xfrm>
-          <a:off x="0" y="0"/>
-          <a:ext cx="0" cy="0"/>
-          <a:chOff x="0" y="0"/>
-          <a:chExt cx="0" cy="0"/>
-        </a:xfrm>
-      </p:grpSpPr>
-      <p:sp>
-        <p:nvSpPr>
-          <p:cNvPr id="2" name="Title 1">
-            <a:extLst>
-              <a:ext uri="{FF2B5EF4-FFF2-40B4-BE49-F238E27FC236}">
-                <a16:creationId xmlns:a16="http://schemas.microsoft.com/office/drawing/2014/main" id="{BE5144C2-6FBD-EAB0-BFE1-5F43BCC848F2}"/>
-              </a:ext>
-            </a:extLst>
-          </p:cNvPr>
-          <p:cNvSpPr>
-            <a:spLocks noGrp="1"/>
-          </p:cNvSpPr>
-          <p:nvPr>
-            <p:ph type="title"/>
-          </p:nvPr>
-        </p:nvSpPr>
-        <p:spPr/>
-        <p:txBody>
-          <a:bodyPr/>
-          <a:lstStyle/>
-          <a:p>
-            <a:endParaRPr lang="en-US"/>
-          </a:p>
-        </p:txBody>
-      </p:sp>
-      <p:sp>
-        <p:nvSpPr>
-          <p:cNvPr id="3" name="Content Placeholder 2">
-            <a:extLst>
-              <a:ext uri="{FF2B5EF4-FFF2-40B4-BE49-F238E27FC236}">
-                <a16:creationId xmlns:a16="http://schemas.microsoft.com/office/drawing/2014/main" id="{7164E9BA-0227-190C-0C54-EC2F5D705386}"/>
-              </a:ext>
-            </a:extLst>
-          </p:cNvPr>
-          <p:cNvSpPr>
-            <a:spLocks noGrp="1"/>
-          </p:cNvSpPr>
-          <p:nvPr>
-            <p:ph idx="1"/>
-          </p:nvPr>
-        </p:nvSpPr>
-        <p:spPr/>
-        <p:txBody>
-          <a:bodyPr/>
-          <a:lstStyle/>
-          <a:p>
-            <a:endParaRPr lang="en-US"/>
-          </a:p>
-        </p:txBody>
-      </p:sp>
-      <p:pic>
-        <p:nvPicPr>
-          <p:cNvPr id="5" name="Picture 4">
-            <a:extLst>
-              <a:ext uri="{FF2B5EF4-FFF2-40B4-BE49-F238E27FC236}">
-                <a16:creationId xmlns:a16="http://schemas.microsoft.com/office/drawing/2014/main" id="{E84891FB-2985-94E9-B6FE-DB6C08B31F63}"/>
-              </a:ext>
-            </a:extLst>
-          </p:cNvPr>
-          <p:cNvPicPr>
-            <a:picLocks noChangeAspect="1"/>
-          </p:cNvPicPr>
-          <p:nvPr/>
-        </p:nvPicPr>
-        <p:blipFill>
-          <a:blip r:embed="rId2"/>
-          <a:stretch>
-            <a:fillRect/>
-          </a:stretch>
-        </p:blipFill>
-        <p:spPr>
-          <a:xfrm>
-            <a:off x="879389" y="0"/>
-            <a:ext cx="4780352" cy="6858000"/>
-          </a:xfrm>
-          <a:prstGeom prst="rect">
-            <a:avLst/>
-          </a:prstGeom>
-        </p:spPr>
-      </p:pic>
-    </p:spTree>
-    <p:extLst>
-      <p:ext uri="{BB962C8B-B14F-4D97-AF65-F5344CB8AC3E}">
-        <p14:creationId xmlns:p14="http://schemas.microsoft.com/office/powerpoint/2010/main" val="750153433"/>
-      </p:ext>
-    </p:extLst>
-  </p:cSld>
-  <p:clrMapOvr>
-    <a:masterClrMapping/>
-  </p:clrMapOvr>
-</p:sld>
-</file>
-
-<file path=ppt/slides/slide13.xml><?xml version="1.0" encoding="utf-8"?>
-<p:sld xmlns:a="http://schemas.openxmlformats.org/drawingml/2006/main" xmlns:r="http://schemas.openxmlformats.org/officeDocument/2006/relationships" xmlns:p="http://schemas.openxmlformats.org/presentationml/2006/main">
-  <p:cSld>
-    <p:spTree>
-      <p:nvGrpSpPr>
-        <p:cNvPr id="1" name=""/>
-        <p:cNvGrpSpPr/>
-        <p:nvPr/>
-      </p:nvGrpSpPr>
-      <p:grpSpPr>
-        <a:xfrm>
-          <a:off x="0" y="0"/>
-          <a:ext cx="0" cy="0"/>
-          <a:chOff x="0" y="0"/>
-          <a:chExt cx="0" cy="0"/>
-        </a:xfrm>
-      </p:grpSpPr>
-      <p:sp>
-        <p:nvSpPr>
-          <p:cNvPr id="2" name="Title 1">
-            <a:extLst>
-              <a:ext uri="{FF2B5EF4-FFF2-40B4-BE49-F238E27FC236}">
-                <a16:creationId xmlns:a16="http://schemas.microsoft.com/office/drawing/2014/main" id="{7B4AEE6D-A3F1-E9E9-FF80-8F5B143F84BD}"/>
-              </a:ext>
-            </a:extLst>
-          </p:cNvPr>
-          <p:cNvSpPr>
-            <a:spLocks noGrp="1"/>
-          </p:cNvSpPr>
-          <p:nvPr>
-            <p:ph type="title"/>
-          </p:nvPr>
-        </p:nvSpPr>
-        <p:spPr/>
-        <p:txBody>
-          <a:bodyPr/>
-          <a:lstStyle/>
-          <a:p>
-            <a:endParaRPr lang="en-US"/>
-          </a:p>
-        </p:txBody>
-      </p:sp>
-      <p:sp>
-        <p:nvSpPr>
-          <p:cNvPr id="3" name="Content Placeholder 2">
-            <a:extLst>
-              <a:ext uri="{FF2B5EF4-FFF2-40B4-BE49-F238E27FC236}">
-                <a16:creationId xmlns:a16="http://schemas.microsoft.com/office/drawing/2014/main" id="{E226320A-54D1-9972-4571-829D88FDA8BB}"/>
-              </a:ext>
-            </a:extLst>
-          </p:cNvPr>
-          <p:cNvSpPr>
-            <a:spLocks noGrp="1"/>
-          </p:cNvSpPr>
-          <p:nvPr>
-            <p:ph idx="1"/>
-          </p:nvPr>
-        </p:nvSpPr>
-        <p:spPr/>
-        <p:txBody>
-          <a:bodyPr/>
-          <a:lstStyle/>
-          <a:p>
-            <a:endParaRPr lang="en-US"/>
+            <a:endParaRPr lang="en-US" dirty="0"/>
           </a:p>
         </p:txBody>
       </p:sp>
@@ -3853,7 +3520,7 @@
 </p:sld>
 </file>
 
-<file path=ppt/slides/slide14.xml><?xml version="1.0" encoding="utf-8"?>
+<file path=ppt/slides/slide11.xml><?xml version="1.0" encoding="utf-8"?>
 <p:sld xmlns:a="http://schemas.openxmlformats.org/drawingml/2006/main" xmlns:r="http://schemas.openxmlformats.org/officeDocument/2006/relationships" xmlns:p="http://schemas.openxmlformats.org/presentationml/2006/main">
   <p:cSld>
     <p:spTree>
@@ -3963,7 +3630,7 @@
 </p:sld>
 </file>
 
-<file path=ppt/slides/slide15.xml><?xml version="1.0" encoding="utf-8"?>
+<file path=ppt/slides/slide12.xml><?xml version="1.0" encoding="utf-8"?>
 <p:sld xmlns:a="http://schemas.openxmlformats.org/drawingml/2006/main" xmlns:r="http://schemas.openxmlformats.org/officeDocument/2006/relationships" xmlns:p="http://schemas.openxmlformats.org/presentationml/2006/main">
   <p:cSld>
     <p:spTree>
@@ -4073,7 +3740,7 @@
 </p:sld>
 </file>
 
-<file path=ppt/slides/slide16.xml><?xml version="1.0" encoding="utf-8"?>
+<file path=ppt/slides/slide13.xml><?xml version="1.0" encoding="utf-8"?>
 <p:sld xmlns:a="http://schemas.openxmlformats.org/drawingml/2006/main" xmlns:r="http://schemas.openxmlformats.org/officeDocument/2006/relationships" xmlns:p="http://schemas.openxmlformats.org/presentationml/2006/main">
   <p:cSld>
     <p:spTree>
@@ -4176,7 +3843,7 @@
 </p:sld>
 </file>
 
-<file path=ppt/slides/slide17.xml><?xml version="1.0" encoding="utf-8"?>
+<file path=ppt/slides/slide14.xml><?xml version="1.0" encoding="utf-8"?>
 <p:sld xmlns:a="http://schemas.openxmlformats.org/drawingml/2006/main" xmlns:r="http://schemas.openxmlformats.org/officeDocument/2006/relationships" xmlns:p="http://schemas.openxmlformats.org/presentationml/2006/main">
   <p:cSld>
     <p:spTree>
@@ -5034,7 +4701,7 @@
           <p:cNvPr id="2" name="Title 1">
             <a:extLst>
               <a:ext uri="{FF2B5EF4-FFF2-40B4-BE49-F238E27FC236}">
-                <a16:creationId xmlns:a16="http://schemas.microsoft.com/office/drawing/2014/main" id="{D182E778-C29C-4AF0-C3CA-1B399A6DD3CF}"/>
+                <a16:creationId xmlns:a16="http://schemas.microsoft.com/office/drawing/2014/main" id="{F2822B0E-0203-DA06-B708-B67B8EAF7F2A}"/>
               </a:ext>
             </a:extLst>
           </p:cNvPr>
@@ -5059,7 +4726,7 @@
           <p:cNvPr id="3" name="Content Placeholder 2">
             <a:extLst>
               <a:ext uri="{FF2B5EF4-FFF2-40B4-BE49-F238E27FC236}">
-                <a16:creationId xmlns:a16="http://schemas.microsoft.com/office/drawing/2014/main" id="{44C1C09A-C471-D30C-2C45-7A56EA6EF03E}"/>
+                <a16:creationId xmlns:a16="http://schemas.microsoft.com/office/drawing/2014/main" id="{A539C5AE-1CC4-6F46-3306-37B11EE86C0A}"/>
               </a:ext>
             </a:extLst>
           </p:cNvPr>
@@ -5084,7 +4751,7 @@
           <p:cNvPr id="5" name="Picture 4">
             <a:extLst>
               <a:ext uri="{FF2B5EF4-FFF2-40B4-BE49-F238E27FC236}">
-                <a16:creationId xmlns:a16="http://schemas.microsoft.com/office/drawing/2014/main" id="{0EFC1215-187D-DE46-1544-9D236846B0AF}"/>
+                <a16:creationId xmlns:a16="http://schemas.microsoft.com/office/drawing/2014/main" id="{8AB542F2-146E-FB9C-4763-825D600F61AD}"/>
               </a:ext>
             </a:extLst>
           </p:cNvPr>
@@ -5101,8 +4768,8 @@
         </p:blipFill>
         <p:spPr>
           <a:xfrm>
-            <a:off x="1631396" y="0"/>
-            <a:ext cx="8929207" cy="6858000"/>
+            <a:off x="84306" y="0"/>
+            <a:ext cx="12023387" cy="6858000"/>
           </a:xfrm>
           <a:prstGeom prst="rect">
             <a:avLst/>
@@ -5112,7 +4779,7 @@
     </p:spTree>
     <p:extLst>
       <p:ext uri="{BB962C8B-B14F-4D97-AF65-F5344CB8AC3E}">
-        <p14:creationId xmlns:p14="http://schemas.microsoft.com/office/powerpoint/2010/main" val="2564279772"/>
+        <p14:creationId xmlns:p14="http://schemas.microsoft.com/office/powerpoint/2010/main" val="1509795331"/>
       </p:ext>
     </p:extLst>
   </p:cSld>
@@ -5144,7 +4811,7 @@
           <p:cNvPr id="2" name="Title 1">
             <a:extLst>
               <a:ext uri="{FF2B5EF4-FFF2-40B4-BE49-F238E27FC236}">
-                <a16:creationId xmlns:a16="http://schemas.microsoft.com/office/drawing/2014/main" id="{6E4B2A3D-150A-C33B-7CAA-693BA1524FEB}"/>
+                <a16:creationId xmlns:a16="http://schemas.microsoft.com/office/drawing/2014/main" id="{BE5144C2-6FBD-EAB0-BFE1-5F43BCC848F2}"/>
               </a:ext>
             </a:extLst>
           </p:cNvPr>
@@ -5169,7 +4836,7 @@
           <p:cNvPr id="3" name="Content Placeholder 2">
             <a:extLst>
               <a:ext uri="{FF2B5EF4-FFF2-40B4-BE49-F238E27FC236}">
-                <a16:creationId xmlns:a16="http://schemas.microsoft.com/office/drawing/2014/main" id="{CE3321AD-DC6D-A7B9-B806-1DDEF2DD5759}"/>
+                <a16:creationId xmlns:a16="http://schemas.microsoft.com/office/drawing/2014/main" id="{7164E9BA-0227-190C-0C54-EC2F5D705386}"/>
               </a:ext>
             </a:extLst>
           </p:cNvPr>
@@ -5194,7 +4861,7 @@
           <p:cNvPr id="5" name="Picture 4">
             <a:extLst>
               <a:ext uri="{FF2B5EF4-FFF2-40B4-BE49-F238E27FC236}">
-                <a16:creationId xmlns:a16="http://schemas.microsoft.com/office/drawing/2014/main" id="{9256D8E3-8B64-4706-C123-9CB6786DE4F4}"/>
+                <a16:creationId xmlns:a16="http://schemas.microsoft.com/office/drawing/2014/main" id="{E84891FB-2985-94E9-B6FE-DB6C08B31F63}"/>
               </a:ext>
             </a:extLst>
           </p:cNvPr>
@@ -5211,8 +4878,8 @@
         </p:blipFill>
         <p:spPr>
           <a:xfrm>
-            <a:off x="625678" y="0"/>
-            <a:ext cx="10940643" cy="6858000"/>
+            <a:off x="879389" y="0"/>
+            <a:ext cx="4780352" cy="6858000"/>
           </a:xfrm>
           <a:prstGeom prst="rect">
             <a:avLst/>
@@ -5222,7 +4889,7 @@
     </p:spTree>
     <p:extLst>
       <p:ext uri="{BB962C8B-B14F-4D97-AF65-F5344CB8AC3E}">
-        <p14:creationId xmlns:p14="http://schemas.microsoft.com/office/powerpoint/2010/main" val="2782608260"/>
+        <p14:creationId xmlns:p14="http://schemas.microsoft.com/office/powerpoint/2010/main" val="750153433"/>
       </p:ext>
     </p:extLst>
   </p:cSld>

</xml_diff>